<commit_message>
Deploying to gh-pages from @ Smithsonian/MitoPilot@b6dc6be66abac4450d7d0d0454c8ab0ba618d4d1 🚀
</commit_message>
<xml_diff>
--- a/reference/figures/workflow_overview.pptx
+++ b/reference/figures/workflow_overview.pptx
@@ -259,7 +259,7 @@
           <a:p>
             <a:fld id="{FA095A4B-E0B2-984D-AE4F-72FF04A7AC22}" type="datetimeFigureOut">
               <a:rPr lang="en-US" smtClean="0"/>
-              <a:t>7/9/26</a:t>
+              <a:t>9/25/26</a:t>
             </a:fld>
             <a:endParaRPr lang="en-US"/>
           </a:p>
@@ -457,7 +457,7 @@
           <a:p>
             <a:fld id="{FA095A4B-E0B2-984D-AE4F-72FF04A7AC22}" type="datetimeFigureOut">
               <a:rPr lang="en-US" smtClean="0"/>
-              <a:t>7/9/26</a:t>
+              <a:t>9/25/26</a:t>
             </a:fld>
             <a:endParaRPr lang="en-US"/>
           </a:p>
@@ -665,7 +665,7 @@
           <a:p>
             <a:fld id="{FA095A4B-E0B2-984D-AE4F-72FF04A7AC22}" type="datetimeFigureOut">
               <a:rPr lang="en-US" smtClean="0"/>
-              <a:t>7/9/26</a:t>
+              <a:t>9/25/26</a:t>
             </a:fld>
             <a:endParaRPr lang="en-US"/>
           </a:p>
@@ -863,7 +863,7 @@
           <a:p>
             <a:fld id="{FA095A4B-E0B2-984D-AE4F-72FF04A7AC22}" type="datetimeFigureOut">
               <a:rPr lang="en-US" smtClean="0"/>
-              <a:t>7/9/26</a:t>
+              <a:t>9/25/26</a:t>
             </a:fld>
             <a:endParaRPr lang="en-US"/>
           </a:p>
@@ -1138,7 +1138,7 @@
           <a:p>
             <a:fld id="{FA095A4B-E0B2-984D-AE4F-72FF04A7AC22}" type="datetimeFigureOut">
               <a:rPr lang="en-US" smtClean="0"/>
-              <a:t>7/9/26</a:t>
+              <a:t>9/25/26</a:t>
             </a:fld>
             <a:endParaRPr lang="en-US"/>
           </a:p>
@@ -1403,7 +1403,7 @@
           <a:p>
             <a:fld id="{FA095A4B-E0B2-984D-AE4F-72FF04A7AC22}" type="datetimeFigureOut">
               <a:rPr lang="en-US" smtClean="0"/>
-              <a:t>7/9/26</a:t>
+              <a:t>9/25/26</a:t>
             </a:fld>
             <a:endParaRPr lang="en-US"/>
           </a:p>
@@ -1815,7 +1815,7 @@
           <a:p>
             <a:fld id="{FA095A4B-E0B2-984D-AE4F-72FF04A7AC22}" type="datetimeFigureOut">
               <a:rPr lang="en-US" smtClean="0"/>
-              <a:t>7/9/26</a:t>
+              <a:t>9/25/26</a:t>
             </a:fld>
             <a:endParaRPr lang="en-US"/>
           </a:p>
@@ -1956,7 +1956,7 @@
           <a:p>
             <a:fld id="{FA095A4B-E0B2-984D-AE4F-72FF04A7AC22}" type="datetimeFigureOut">
               <a:rPr lang="en-US" smtClean="0"/>
-              <a:t>7/9/26</a:t>
+              <a:t>9/25/26</a:t>
             </a:fld>
             <a:endParaRPr lang="en-US"/>
           </a:p>
@@ -2069,7 +2069,7 @@
           <a:p>
             <a:fld id="{FA095A4B-E0B2-984D-AE4F-72FF04A7AC22}" type="datetimeFigureOut">
               <a:rPr lang="en-US" smtClean="0"/>
-              <a:t>7/9/26</a:t>
+              <a:t>9/25/26</a:t>
             </a:fld>
             <a:endParaRPr lang="en-US"/>
           </a:p>
@@ -2380,7 +2380,7 @@
           <a:p>
             <a:fld id="{FA095A4B-E0B2-984D-AE4F-72FF04A7AC22}" type="datetimeFigureOut">
               <a:rPr lang="en-US" smtClean="0"/>
-              <a:t>7/9/26</a:t>
+              <a:t>9/25/26</a:t>
             </a:fld>
             <a:endParaRPr lang="en-US"/>
           </a:p>
@@ -2668,7 +2668,7 @@
           <a:p>
             <a:fld id="{FA095A4B-E0B2-984D-AE4F-72FF04A7AC22}" type="datetimeFigureOut">
               <a:rPr lang="en-US" smtClean="0"/>
-              <a:t>7/9/26</a:t>
+              <a:t>9/25/26</a:t>
             </a:fld>
             <a:endParaRPr lang="en-US"/>
           </a:p>
@@ -2909,7 +2909,7 @@
           <a:p>
             <a:fld id="{FA095A4B-E0B2-984D-AE4F-72FF04A7AC22}" type="datetimeFigureOut">
               <a:rPr lang="en-US" smtClean="0"/>
-              <a:t>7/9/26</a:t>
+              <a:t>9/25/26</a:t>
             </a:fld>
             <a:endParaRPr lang="en-US"/>
           </a:p>
@@ -4999,8 +4999,8 @@
         </p:blipFill>
         <p:spPr bwMode="auto">
           <a:xfrm>
-            <a:off x="1212140" y="5053290"/>
-            <a:ext cx="1176151" cy="1176151"/>
+            <a:off x="1614058" y="5219314"/>
+            <a:ext cx="822521" cy="822521"/>
           </a:xfrm>
           <a:prstGeom prst="rect">
             <a:avLst/>
@@ -5572,6 +5572,67 @@
           </a:p>
         </p:txBody>
       </p:sp>
+      <p:pic>
+        <p:nvPicPr>
+          <p:cNvPr id="34" name="Picture 33" descr="GBIF logo [IMAGE] | EurekAlert! Science News Releases">
+            <a:extLst>
+              <a:ext uri="{FF2B5EF4-FFF2-40B4-BE49-F238E27FC236}">
+                <a16:creationId xmlns:a16="http://schemas.microsoft.com/office/drawing/2014/main" id="{0DB84CA3-7353-2D61-8C4E-D947833DD7C8}"/>
+              </a:ext>
+            </a:extLst>
+          </p:cNvPr>
+          <p:cNvPicPr>
+            <a:picLocks noChangeAspect="1"/>
+          </p:cNvPicPr>
+          <p:nvPr/>
+        </p:nvPicPr>
+        <p:blipFill>
+          <a:blip r:embed="rId6"/>
+          <a:stretch>
+            <a:fillRect/>
+          </a:stretch>
+        </p:blipFill>
+        <p:spPr>
+          <a:xfrm>
+            <a:off x="791525" y="5157734"/>
+            <a:ext cx="964288" cy="482144"/>
+          </a:xfrm>
+          <a:prstGeom prst="rect">
+            <a:avLst/>
+          </a:prstGeom>
+        </p:spPr>
+      </p:pic>
+      <p:pic>
+        <p:nvPicPr>
+          <p:cNvPr id="35" name="Picture 34" descr="Design logo for geome| concursos de | 99designs">
+            <a:extLst>
+              <a:ext uri="{FF2B5EF4-FFF2-40B4-BE49-F238E27FC236}">
+                <a16:creationId xmlns:a16="http://schemas.microsoft.com/office/drawing/2014/main" id="{51996373-8BB1-6E67-E418-40E0B02F707B}"/>
+              </a:ext>
+            </a:extLst>
+          </p:cNvPr>
+          <p:cNvPicPr>
+            <a:picLocks noChangeAspect="1"/>
+          </p:cNvPicPr>
+          <p:nvPr/>
+        </p:nvPicPr>
+        <p:blipFill>
+          <a:blip r:embed="rId7"/>
+          <a:srcRect l="19288" t="36845" r="19713" b="34594"/>
+          <a:stretch>
+            <a:fillRect/>
+          </a:stretch>
+        </p:blipFill>
+        <p:spPr>
+          <a:xfrm>
+            <a:off x="879682" y="5633403"/>
+            <a:ext cx="788798" cy="369332"/>
+          </a:xfrm>
+          <a:prstGeom prst="rect">
+            <a:avLst/>
+          </a:prstGeom>
+        </p:spPr>
+      </p:pic>
     </p:spTree>
     <p:extLst>
       <p:ext uri="{BB962C8B-B14F-4D97-AF65-F5344CB8AC3E}">

</xml_diff>

<commit_message>
Deploying to gh-pages from @ Smithsonian/MitoPilot@c0b93e46dce74cf696e4a37ffafc692c57e61b4f 🚀
</commit_message>
<xml_diff>
--- a/reference/figures/workflow_overview.pptx
+++ b/reference/figures/workflow_overview.pptx
@@ -259,7 +259,7 @@
           <a:p>
             <a:fld id="{FA095A4B-E0B2-984D-AE4F-72FF04A7AC22}" type="datetimeFigureOut">
               <a:rPr lang="en-US" smtClean="0"/>
-              <a:t>9/25/26</a:t>
+              <a:t>9/29/26</a:t>
             </a:fld>
             <a:endParaRPr lang="en-US"/>
           </a:p>
@@ -457,7 +457,7 @@
           <a:p>
             <a:fld id="{FA095A4B-E0B2-984D-AE4F-72FF04A7AC22}" type="datetimeFigureOut">
               <a:rPr lang="en-US" smtClean="0"/>
-              <a:t>9/25/26</a:t>
+              <a:t>9/29/26</a:t>
             </a:fld>
             <a:endParaRPr lang="en-US"/>
           </a:p>
@@ -665,7 +665,7 @@
           <a:p>
             <a:fld id="{FA095A4B-E0B2-984D-AE4F-72FF04A7AC22}" type="datetimeFigureOut">
               <a:rPr lang="en-US" smtClean="0"/>
-              <a:t>9/25/26</a:t>
+              <a:t>9/29/26</a:t>
             </a:fld>
             <a:endParaRPr lang="en-US"/>
           </a:p>
@@ -863,7 +863,7 @@
           <a:p>
             <a:fld id="{FA095A4B-E0B2-984D-AE4F-72FF04A7AC22}" type="datetimeFigureOut">
               <a:rPr lang="en-US" smtClean="0"/>
-              <a:t>9/25/26</a:t>
+              <a:t>9/29/26</a:t>
             </a:fld>
             <a:endParaRPr lang="en-US"/>
           </a:p>
@@ -1138,7 +1138,7 @@
           <a:p>
             <a:fld id="{FA095A4B-E0B2-984D-AE4F-72FF04A7AC22}" type="datetimeFigureOut">
               <a:rPr lang="en-US" smtClean="0"/>
-              <a:t>9/25/26</a:t>
+              <a:t>9/29/26</a:t>
             </a:fld>
             <a:endParaRPr lang="en-US"/>
           </a:p>
@@ -1403,7 +1403,7 @@
           <a:p>
             <a:fld id="{FA095A4B-E0B2-984D-AE4F-72FF04A7AC22}" type="datetimeFigureOut">
               <a:rPr lang="en-US" smtClean="0"/>
-              <a:t>9/25/26</a:t>
+              <a:t>9/29/26</a:t>
             </a:fld>
             <a:endParaRPr lang="en-US"/>
           </a:p>
@@ -1815,7 +1815,7 @@
           <a:p>
             <a:fld id="{FA095A4B-E0B2-984D-AE4F-72FF04A7AC22}" type="datetimeFigureOut">
               <a:rPr lang="en-US" smtClean="0"/>
-              <a:t>9/25/26</a:t>
+              <a:t>9/29/26</a:t>
             </a:fld>
             <a:endParaRPr lang="en-US"/>
           </a:p>
@@ -1956,7 +1956,7 @@
           <a:p>
             <a:fld id="{FA095A4B-E0B2-984D-AE4F-72FF04A7AC22}" type="datetimeFigureOut">
               <a:rPr lang="en-US" smtClean="0"/>
-              <a:t>9/25/26</a:t>
+              <a:t>9/29/26</a:t>
             </a:fld>
             <a:endParaRPr lang="en-US"/>
           </a:p>
@@ -2069,7 +2069,7 @@
           <a:p>
             <a:fld id="{FA095A4B-E0B2-984D-AE4F-72FF04A7AC22}" type="datetimeFigureOut">
               <a:rPr lang="en-US" smtClean="0"/>
-              <a:t>9/25/26</a:t>
+              <a:t>9/29/26</a:t>
             </a:fld>
             <a:endParaRPr lang="en-US"/>
           </a:p>
@@ -2380,7 +2380,7 @@
           <a:p>
             <a:fld id="{FA095A4B-E0B2-984D-AE4F-72FF04A7AC22}" type="datetimeFigureOut">
               <a:rPr lang="en-US" smtClean="0"/>
-              <a:t>9/25/26</a:t>
+              <a:t>9/29/26</a:t>
             </a:fld>
             <a:endParaRPr lang="en-US"/>
           </a:p>
@@ -2668,7 +2668,7 @@
           <a:p>
             <a:fld id="{FA095A4B-E0B2-984D-AE4F-72FF04A7AC22}" type="datetimeFigureOut">
               <a:rPr lang="en-US" smtClean="0"/>
-              <a:t>9/25/26</a:t>
+              <a:t>9/29/26</a:t>
             </a:fld>
             <a:endParaRPr lang="en-US"/>
           </a:p>
@@ -2909,7 +2909,7 @@
           <a:p>
             <a:fld id="{FA095A4B-E0B2-984D-AE4F-72FF04A7AC22}" type="datetimeFigureOut">
               <a:rPr lang="en-US" smtClean="0"/>
-              <a:t>9/25/26</a:t>
+              <a:t>9/29/26</a:t>
             </a:fld>
             <a:endParaRPr lang="en-US"/>
           </a:p>
@@ -4970,53 +4970,6 @@
           </a:p>
         </p:txBody>
       </p:sp>
-      <p:pic>
-        <p:nvPicPr>
-          <p:cNvPr id="6" name="Picture 2" descr="Spreadsheet document symbol | Free SVG">
-            <a:extLst>
-              <a:ext uri="{FF2B5EF4-FFF2-40B4-BE49-F238E27FC236}">
-                <a16:creationId xmlns:a16="http://schemas.microsoft.com/office/drawing/2014/main" id="{89D67121-A8B0-9A58-DD50-E83C92F2F64F}"/>
-              </a:ext>
-            </a:extLst>
-          </p:cNvPr>
-          <p:cNvPicPr>
-            <a:picLocks noChangeAspect="1" noChangeArrowheads="1"/>
-          </p:cNvPicPr>
-          <p:nvPr/>
-        </p:nvPicPr>
-        <p:blipFill>
-          <a:blip r:embed="rId5">
-            <a:extLst>
-              <a:ext uri="{28A0092B-C50C-407E-A947-70E740481C1C}">
-                <a14:useLocalDpi xmlns:a14="http://schemas.microsoft.com/office/drawing/2010/main" val="0"/>
-              </a:ext>
-            </a:extLst>
-          </a:blip>
-          <a:srcRect/>
-          <a:stretch>
-            <a:fillRect/>
-          </a:stretch>
-        </p:blipFill>
-        <p:spPr bwMode="auto">
-          <a:xfrm>
-            <a:off x="1614058" y="5219314"/>
-            <a:ext cx="822521" cy="822521"/>
-          </a:xfrm>
-          <a:prstGeom prst="rect">
-            <a:avLst/>
-          </a:prstGeom>
-          <a:noFill/>
-          <a:extLst>
-            <a:ext uri="{909E8E84-426E-40DD-AFC4-6F175D3DCCD1}">
-              <a14:hiddenFill xmlns:a14="http://schemas.microsoft.com/office/drawing/2010/main">
-                <a:solidFill>
-                  <a:srgbClr val="FFFFFF"/>
-                </a:solidFill>
-              </a14:hiddenFill>
-            </a:ext>
-          </a:extLst>
-        </p:spPr>
-      </p:pic>
       <p:sp>
         <p:nvSpPr>
           <p:cNvPr id="7" name="TextBox 6">
@@ -5587,14 +5540,14 @@
           <p:nvPr/>
         </p:nvPicPr>
         <p:blipFill>
-          <a:blip r:embed="rId6"/>
+          <a:blip r:embed="rId5"/>
           <a:stretch>
             <a:fillRect/>
           </a:stretch>
         </p:blipFill>
         <p:spPr>
           <a:xfrm>
-            <a:off x="791525" y="5157734"/>
+            <a:off x="739523" y="5007480"/>
             <a:ext cx="964288" cy="482144"/>
           </a:xfrm>
           <a:prstGeom prst="rect">
@@ -5617,7 +5570,7 @@
           <p:nvPr/>
         </p:nvPicPr>
         <p:blipFill>
-          <a:blip r:embed="rId7"/>
+          <a:blip r:embed="rId6"/>
           <a:srcRect l="19288" t="36845" r="19713" b="34594"/>
           <a:stretch>
             <a:fillRect/>
@@ -5625,12 +5578,106 @@
         </p:blipFill>
         <p:spPr>
           <a:xfrm>
-            <a:off x="879682" y="5633403"/>
+            <a:off x="1608285" y="5751952"/>
             <a:ext cx="788798" cy="369332"/>
           </a:xfrm>
           <a:prstGeom prst="rect">
             <a:avLst/>
           </a:prstGeom>
+        </p:spPr>
+      </p:pic>
+      <p:pic>
+        <p:nvPicPr>
+          <p:cNvPr id="14" name="Picture 6" descr="NCBI BLAST - Desktop App for Mac, Windows (PC) - WebCatalog">
+            <a:extLst>
+              <a:ext uri="{FF2B5EF4-FFF2-40B4-BE49-F238E27FC236}">
+                <a16:creationId xmlns:a16="http://schemas.microsoft.com/office/drawing/2014/main" id="{7194E7EB-C037-BE78-4D91-22AF47629A3C}"/>
+              </a:ext>
+            </a:extLst>
+          </p:cNvPr>
+          <p:cNvPicPr>
+            <a:picLocks noChangeAspect="1" noChangeArrowheads="1"/>
+          </p:cNvPicPr>
+          <p:nvPr/>
+        </p:nvPicPr>
+        <p:blipFill>
+          <a:blip r:embed="rId2">
+            <a:extLst>
+              <a:ext uri="{28A0092B-C50C-407E-A947-70E740481C1C}">
+                <a14:useLocalDpi xmlns:a14="http://schemas.microsoft.com/office/drawing/2010/main" val="0"/>
+              </a:ext>
+            </a:extLst>
+          </a:blip>
+          <a:srcRect/>
+          <a:stretch>
+            <a:fillRect/>
+          </a:stretch>
+        </p:blipFill>
+        <p:spPr bwMode="auto">
+          <a:xfrm>
+            <a:off x="861352" y="5496733"/>
+            <a:ext cx="658992" cy="658992"/>
+          </a:xfrm>
+          <a:prstGeom prst="rect">
+            <a:avLst/>
+          </a:prstGeom>
+          <a:noFill/>
+          <a:extLst>
+            <a:ext uri="{909E8E84-426E-40DD-AFC4-6F175D3DCCD1}">
+              <a14:hiddenFill xmlns:a14="http://schemas.microsoft.com/office/drawing/2010/main">
+                <a:solidFill>
+                  <a:srgbClr val="FFFFFF"/>
+                </a:solidFill>
+              </a14:hiddenFill>
+            </a:ext>
+          </a:extLst>
+        </p:spPr>
+      </p:pic>
+      <p:pic>
+        <p:nvPicPr>
+          <p:cNvPr id="6" name="Picture 2" descr="Spreadsheet document symbol | Free SVG">
+            <a:extLst>
+              <a:ext uri="{FF2B5EF4-FFF2-40B4-BE49-F238E27FC236}">
+                <a16:creationId xmlns:a16="http://schemas.microsoft.com/office/drawing/2014/main" id="{89D67121-A8B0-9A58-DD50-E83C92F2F64F}"/>
+              </a:ext>
+            </a:extLst>
+          </p:cNvPr>
+          <p:cNvPicPr>
+            <a:picLocks noChangeAspect="1" noChangeArrowheads="1"/>
+          </p:cNvPicPr>
+          <p:nvPr/>
+        </p:nvPicPr>
+        <p:blipFill>
+          <a:blip r:embed="rId7">
+            <a:extLst>
+              <a:ext uri="{28A0092B-C50C-407E-A947-70E740481C1C}">
+                <a14:useLocalDpi xmlns:a14="http://schemas.microsoft.com/office/drawing/2010/main" val="0"/>
+              </a:ext>
+            </a:extLst>
+          </a:blip>
+          <a:srcRect/>
+          <a:stretch>
+            <a:fillRect/>
+          </a:stretch>
+        </p:blipFill>
+        <p:spPr bwMode="auto">
+          <a:xfrm>
+            <a:off x="1630506" y="5041569"/>
+            <a:ext cx="730702" cy="730702"/>
+          </a:xfrm>
+          <a:prstGeom prst="rect">
+            <a:avLst/>
+          </a:prstGeom>
+          <a:noFill/>
+          <a:extLst>
+            <a:ext uri="{909E8E84-426E-40DD-AFC4-6F175D3DCCD1}">
+              <a14:hiddenFill xmlns:a14="http://schemas.microsoft.com/office/drawing/2010/main">
+                <a:solidFill>
+                  <a:srgbClr val="FFFFFF"/>
+                </a:solidFill>
+              </a14:hiddenFill>
+            </a:ext>
+          </a:extLst>
         </p:spPr>
       </p:pic>
     </p:spTree>

</xml_diff>